<commit_message>
fix(scraper): manejo inteligente de sala de espera (Queue-It) y actualizacion de presentacion
</commit_message>
<xml_diff>
--- a/Defensa_ETL_Nubox_AlexisTaha.pptx
+++ b/Defensa_ETL_Nubox_AlexisTaha.pptx
@@ -11384,14 +11384,14 @@
       </p:sp>
       <p:sp>
         <p:nvSpPr>
-          <p:cNvPr id="5" name="TextBox 4"/>
+          <p:cNvPr id="33" name="TextBox 32"/>
           <p:cNvSpPr txBox="1"/>
           <p:nvPr/>
         </p:nvSpPr>
         <p:spPr>
           <a:xfrm>
-            <a:off x="731520" y="1554480"/>
-            <a:ext cx="5029200" cy="365760"/>
+            <a:off x="731520" y="6400800"/>
+            <a:ext cx="10698480" cy="365760"/>
           </a:xfrm>
           <a:prstGeom prst="rect">
             <a:avLst/>
@@ -11404,8 +11404,8 @@
           </a:bodyPr>
           <a:lstStyle/>
           <a:p>
-            <a:pPr algn="l">
-              <a:defRPr sz="1800" b="1">
+            <a:pPr algn="ctr">
+              <a:defRPr sz="1600" b="1">
                 <a:solidFill>
                   <a:srgbClr val="1B3A5C"/>
                 </a:solidFill>
@@ -11413,6 +11413,41 @@
               </a:defRPr>
             </a:pPr>
             <a:r>
+              <a:t>Gracias! Preguntas?  |  Alexis Taha  |  Data Engineer Semi-Senior</a:t>
+            </a:r>
+          </a:p>
+        </p:txBody>
+      </p:sp>
+      <p:sp>
+        <p:nvSpPr>
+          <p:cNvPr id="34" name="TextBox 33"/>
+          <p:cNvSpPr txBox="1"/>
+          <p:nvPr/>
+        </p:nvSpPr>
+        <p:spPr>
+          <a:xfrm>
+            <a:off x="731520" y="1554480"/>
+            <a:ext cx="4572000" cy="320040"/>
+          </a:xfrm>
+          <a:prstGeom prst="rect">
+            <a:avLst/>
+          </a:prstGeom>
+          <a:noFill/>
+        </p:spPr>
+        <p:txBody>
+          <a:bodyPr wrap="square">
+            <a:spAutoFit/>
+          </a:bodyPr>
+          <a:lstStyle/>
+          <a:p>
+            <a:pPr algn="l"/>
+            <a:r>
+              <a:rPr sz="1600" b="1">
+                <a:solidFill>
+                  <a:srgbClr val="1B2A4A"/>
+                </a:solidFill>
+                <a:latin typeface="Calibri"/>
+              </a:rPr>
               <a:t>Entregables solicitados</a:t>
             </a:r>
           </a:p>
@@ -11420,27 +11455,24 @@
       </p:sp>
       <p:sp>
         <p:nvSpPr>
-          <p:cNvPr id="6" name="Rounded Rectangle 5"/>
+          <p:cNvPr id="35" name="Rounded Rectangle 34"/>
           <p:cNvSpPr/>
           <p:nvPr/>
         </p:nvSpPr>
         <p:spPr>
           <a:xfrm>
-            <a:off x="731520" y="2103120"/>
-            <a:ext cx="5303520" cy="777240"/>
+            <a:off x="731520" y="1920000"/>
+            <a:ext cx="5000000" cy="500000"/>
           </a:xfrm>
           <a:prstGeom prst="roundRect">
             <a:avLst/>
           </a:prstGeom>
           <a:solidFill>
-            <a:srgbClr val="FFFFFF"/>
+            <a:srgbClr val="F0F2F5"/>
           </a:solidFill>
-          <a:ln w="12700">
-            <a:solidFill>
-              <a:srgbClr val="D0DEED"/>
-            </a:solidFill>
+          <a:ln>
+            <a:noFill/>
           </a:ln>
-          <a:effectLst/>
         </p:spPr>
         <p:style>
           <a:lnRef idx="1">
@@ -11461,31 +11493,29 @@
           <a:lstStyle/>
           <a:p>
             <a:pPr algn="ctr"/>
-            <a:endParaRPr/>
-          </a:p>
-        </p:txBody>
-      </p:sp>
-      <p:sp>
-        <p:nvSpPr>
-          <p:cNvPr id="7" name="Rectangle 6"/>
+          </a:p>
+        </p:txBody>
+      </p:sp>
+      <p:sp>
+        <p:nvSpPr>
+          <p:cNvPr id="36" name="Rectangle 35"/>
           <p:cNvSpPr/>
           <p:nvPr/>
         </p:nvSpPr>
         <p:spPr>
           <a:xfrm>
-            <a:off x="731520" y="2103120"/>
-            <a:ext cx="54864" cy="777240"/>
+            <a:off x="731520" y="1920000"/>
+            <a:ext cx="45720" cy="500000"/>
           </a:xfrm>
           <a:prstGeom prst="rect">
             <a:avLst/>
           </a:prstGeom>
           <a:solidFill>
-            <a:srgbClr val="38A169"/>
+            <a:srgbClr val="2ECC71"/>
           </a:solidFill>
           <a:ln>
             <a:noFill/>
           </a:ln>
-          <a:effectLst/>
         </p:spPr>
         <p:style>
           <a:lnRef idx="1">
@@ -11506,31 +11536,29 @@
           <a:lstStyle/>
           <a:p>
             <a:pPr algn="ctr"/>
-            <a:endParaRPr/>
-          </a:p>
-        </p:txBody>
-      </p:sp>
-      <p:sp>
-        <p:nvSpPr>
-          <p:cNvPr id="8" name="Oval 7"/>
+          </a:p>
+        </p:txBody>
+      </p:sp>
+      <p:sp>
+        <p:nvSpPr>
+          <p:cNvPr id="37" name="Oval 36"/>
           <p:cNvSpPr/>
           <p:nvPr/>
         </p:nvSpPr>
         <p:spPr>
           <a:xfrm>
-            <a:off x="960120" y="2304288"/>
-            <a:ext cx="365760" cy="365760"/>
+            <a:off x="851520" y="2020000"/>
+            <a:ext cx="280000" cy="280000"/>
           </a:xfrm>
           <a:prstGeom prst="ellipse">
             <a:avLst/>
           </a:prstGeom>
           <a:solidFill>
-            <a:srgbClr val="38A169"/>
+            <a:srgbClr val="2ECC71"/>
           </a:solidFill>
           <a:ln>
             <a:noFill/>
           </a:ln>
-          <a:effectLst/>
         </p:spPr>
         <p:style>
           <a:lnRef idx="1">
@@ -11550,30 +11578,28 @@
           <a:bodyPr rtlCol="0" anchor="ctr"/>
           <a:lstStyle/>
           <a:p>
-            <a:pPr algn="ctr">
-              <a:defRPr sz="1000" b="1">
+            <a:pPr algn="ctr"/>
+            <a:r>
+              <a:rPr sz="1000" b="1">
                 <a:solidFill>
                   <a:srgbClr val="FFFFFF"/>
                 </a:solidFill>
-                <a:latin typeface="Calibri"/>
-              </a:defRPr>
-            </a:pPr>
-            <a:r>
-              <a:t>ok</a:t>
-            </a:r>
-          </a:p>
-        </p:txBody>
-      </p:sp>
-      <p:sp>
-        <p:nvSpPr>
-          <p:cNvPr id="9" name="TextBox 8"/>
+              </a:rPr>
+              <a:t>✓</a:t>
+            </a:r>
+          </a:p>
+        </p:txBody>
+      </p:sp>
+      <p:sp>
+        <p:nvSpPr>
+          <p:cNvPr id="38" name="TextBox 37"/>
           <p:cNvSpPr txBox="1"/>
           <p:nvPr/>
         </p:nvSpPr>
         <p:spPr>
           <a:xfrm>
-            <a:off x="1463040" y="2176272"/>
-            <a:ext cx="4389120" cy="320040"/>
+            <a:off x="1231520" y="1965000"/>
+            <a:ext cx="4300000" cy="200000"/>
           </a:xfrm>
           <a:prstGeom prst="rect">
             <a:avLst/>
@@ -11586,30 +11612,29 @@
           </a:bodyPr>
           <a:lstStyle/>
           <a:p>
-            <a:pPr algn="l">
-              <a:defRPr sz="1400" b="1">
-                <a:solidFill>
-                  <a:srgbClr val="1B3A5C"/>
-                </a:solidFill>
-                <a:latin typeface="Calibri"/>
-              </a:defRPr>
-            </a:pPr>
-            <a:r>
-              <a:t>Presentacion 8-10 laminas</a:t>
-            </a:r>
-          </a:p>
-        </p:txBody>
-      </p:sp>
-      <p:sp>
-        <p:nvSpPr>
-          <p:cNvPr id="10" name="TextBox 9"/>
+            <a:pPr algn="l"/>
+            <a:r>
+              <a:rPr sz="1100" b="1">
+                <a:solidFill>
+                  <a:srgbClr val="1B2A4A"/>
+                </a:solidFill>
+                <a:latin typeface="Calibri"/>
+              </a:rPr>
+              <a:t>Presentación 8-10 láminas</a:t>
+            </a:r>
+          </a:p>
+        </p:txBody>
+      </p:sp>
+      <p:sp>
+        <p:nvSpPr>
+          <p:cNvPr id="39" name="TextBox 38"/>
           <p:cNvSpPr txBox="1"/>
           <p:nvPr/>
         </p:nvSpPr>
         <p:spPr>
           <a:xfrm>
-            <a:off x="1463040" y="2514600"/>
-            <a:ext cx="4389120" cy="320040"/>
+            <a:off x="1231520" y="2180000"/>
+            <a:ext cx="4300000" cy="200000"/>
           </a:xfrm>
           <a:prstGeom prst="rect">
             <a:avLst/>
@@ -11622,43 +11647,39 @@
           </a:bodyPr>
           <a:lstStyle/>
           <a:p>
-            <a:pPr algn="l">
-              <a:defRPr sz="1100" b="0">
-                <a:solidFill>
-                  <a:srgbClr val="4A5568"/>
-                </a:solidFill>
-                <a:latin typeface="Calibri"/>
-              </a:defRPr>
-            </a:pPr>
-            <a:r>
-              <a:t>Problema, flujo, modulos, regla, modelo de datos, desafios, cloud</a:t>
-            </a:r>
-          </a:p>
-        </p:txBody>
-      </p:sp>
-      <p:sp>
-        <p:nvSpPr>
-          <p:cNvPr id="11" name="Rounded Rectangle 10"/>
+            <a:pPr algn="l"/>
+            <a:r>
+              <a:rPr sz="800" b="0">
+                <a:solidFill>
+                  <a:srgbClr val="8A95A5"/>
+                </a:solidFill>
+                <a:latin typeface="Calibri"/>
+              </a:rPr>
+              <a:t>Problema, flujo, módulos, regla, modelo de datos, desafíos, cloud</a:t>
+            </a:r>
+          </a:p>
+        </p:txBody>
+      </p:sp>
+      <p:sp>
+        <p:nvSpPr>
+          <p:cNvPr id="40" name="Rounded Rectangle 39"/>
           <p:cNvSpPr/>
           <p:nvPr/>
         </p:nvSpPr>
         <p:spPr>
           <a:xfrm>
-            <a:off x="731520" y="2971800"/>
-            <a:ext cx="5303520" cy="777240"/>
+            <a:off x="731520" y="2480000"/>
+            <a:ext cx="5000000" cy="500000"/>
           </a:xfrm>
           <a:prstGeom prst="roundRect">
             <a:avLst/>
           </a:prstGeom>
           <a:solidFill>
-            <a:srgbClr val="FFFFFF"/>
+            <a:srgbClr val="F0F2F5"/>
           </a:solidFill>
-          <a:ln w="12700">
-            <a:solidFill>
-              <a:srgbClr val="D0DEED"/>
-            </a:solidFill>
+          <a:ln>
+            <a:noFill/>
           </a:ln>
-          <a:effectLst/>
         </p:spPr>
         <p:style>
           <a:lnRef idx="1">
@@ -11679,31 +11700,29 @@
           <a:lstStyle/>
           <a:p>
             <a:pPr algn="ctr"/>
-            <a:endParaRPr/>
-          </a:p>
-        </p:txBody>
-      </p:sp>
-      <p:sp>
-        <p:nvSpPr>
-          <p:cNvPr id="12" name="Rectangle 11"/>
+          </a:p>
+        </p:txBody>
+      </p:sp>
+      <p:sp>
+        <p:nvSpPr>
+          <p:cNvPr id="41" name="Rectangle 40"/>
           <p:cNvSpPr/>
           <p:nvPr/>
         </p:nvSpPr>
         <p:spPr>
           <a:xfrm>
-            <a:off x="731520" y="2971800"/>
-            <a:ext cx="54864" cy="777240"/>
+            <a:off x="731520" y="2480000"/>
+            <a:ext cx="45720" cy="500000"/>
           </a:xfrm>
           <a:prstGeom prst="rect">
             <a:avLst/>
           </a:prstGeom>
           <a:solidFill>
-            <a:srgbClr val="38A169"/>
+            <a:srgbClr val="2ECC71"/>
           </a:solidFill>
           <a:ln>
             <a:noFill/>
           </a:ln>
-          <a:effectLst/>
         </p:spPr>
         <p:style>
           <a:lnRef idx="1">
@@ -11724,31 +11743,29 @@
           <a:lstStyle/>
           <a:p>
             <a:pPr algn="ctr"/>
-            <a:endParaRPr/>
-          </a:p>
-        </p:txBody>
-      </p:sp>
-      <p:sp>
-        <p:nvSpPr>
-          <p:cNvPr id="13" name="Oval 12"/>
+          </a:p>
+        </p:txBody>
+      </p:sp>
+      <p:sp>
+        <p:nvSpPr>
+          <p:cNvPr id="42" name="Oval 41"/>
           <p:cNvSpPr/>
           <p:nvPr/>
         </p:nvSpPr>
         <p:spPr>
           <a:xfrm>
-            <a:off x="960120" y="3172968"/>
-            <a:ext cx="365760" cy="365760"/>
+            <a:off x="851520" y="2580000"/>
+            <a:ext cx="280000" cy="280000"/>
           </a:xfrm>
           <a:prstGeom prst="ellipse">
             <a:avLst/>
           </a:prstGeom>
           <a:solidFill>
-            <a:srgbClr val="38A169"/>
+            <a:srgbClr val="2ECC71"/>
           </a:solidFill>
           <a:ln>
             <a:noFill/>
           </a:ln>
-          <a:effectLst/>
         </p:spPr>
         <p:style>
           <a:lnRef idx="1">
@@ -11768,30 +11785,28 @@
           <a:bodyPr rtlCol="0" anchor="ctr"/>
           <a:lstStyle/>
           <a:p>
-            <a:pPr algn="ctr">
-              <a:defRPr sz="1000" b="1">
+            <a:pPr algn="ctr"/>
+            <a:r>
+              <a:rPr sz="1000" b="1">
                 <a:solidFill>
                   <a:srgbClr val="FFFFFF"/>
                 </a:solidFill>
-                <a:latin typeface="Calibri"/>
-              </a:defRPr>
-            </a:pPr>
-            <a:r>
-              <a:t>ok</a:t>
-            </a:r>
-          </a:p>
-        </p:txBody>
-      </p:sp>
-      <p:sp>
-        <p:nvSpPr>
-          <p:cNvPr id="14" name="TextBox 13"/>
+              </a:rPr>
+              <a:t>✓</a:t>
+            </a:r>
+          </a:p>
+        </p:txBody>
+      </p:sp>
+      <p:sp>
+        <p:nvSpPr>
+          <p:cNvPr id="43" name="TextBox 42"/>
           <p:cNvSpPr txBox="1"/>
           <p:nvPr/>
         </p:nvSpPr>
         <p:spPr>
           <a:xfrm>
-            <a:off x="1463040" y="3044952"/>
-            <a:ext cx="4389120" cy="320040"/>
+            <a:off x="1231520" y="2525000"/>
+            <a:ext cx="4300000" cy="200000"/>
           </a:xfrm>
           <a:prstGeom prst="rect">
             <a:avLst/>
@@ -11804,15 +11819,14 @@
           </a:bodyPr>
           <a:lstStyle/>
           <a:p>
-            <a:pPr algn="l">
-              <a:defRPr sz="1400" b="1">
-                <a:solidFill>
-                  <a:srgbClr val="1B3A5C"/>
-                </a:solidFill>
-                <a:latin typeface="Calibri"/>
-              </a:defRPr>
-            </a:pPr>
-            <a:r>
+            <a:pPr algn="l"/>
+            <a:r>
+              <a:rPr sz="1100" b="1">
+                <a:solidFill>
+                  <a:srgbClr val="1B2A4A"/>
+                </a:solidFill>
+                <a:latin typeface="Calibri"/>
+              </a:rPr>
               <a:t>Diagrama de flujo</a:t>
             </a:r>
           </a:p>
@@ -11820,14 +11834,14 @@
       </p:sp>
       <p:sp>
         <p:nvSpPr>
-          <p:cNvPr id="15" name="TextBox 14"/>
+          <p:cNvPr id="44" name="TextBox 43"/>
           <p:cNvSpPr txBox="1"/>
           <p:nvPr/>
         </p:nvSpPr>
         <p:spPr>
           <a:xfrm>
-            <a:off x="1463040" y="3383280"/>
-            <a:ext cx="4389120" cy="320040"/>
+            <a:off x="1231520" y="2740000"/>
+            <a:ext cx="4300000" cy="200000"/>
           </a:xfrm>
           <a:prstGeom prst="rect">
             <a:avLst/>
@@ -11840,43 +11854,39 @@
           </a:bodyPr>
           <a:lstStyle/>
           <a:p>
-            <a:pPr algn="l">
-              <a:defRPr sz="1100" b="0">
-                <a:solidFill>
-                  <a:srgbClr val="4A5568"/>
-                </a:solidFill>
-                <a:latin typeface="Calibri"/>
-              </a:defRPr>
-            </a:pPr>
-            <a:r>
-              <a:t>Lectura -&gt; validacion -&gt; consulta SII -&gt; clasificacion -&gt; persistencia -&gt; cuarentena</a:t>
-            </a:r>
-          </a:p>
-        </p:txBody>
-      </p:sp>
-      <p:sp>
-        <p:nvSpPr>
-          <p:cNvPr id="16" name="Rounded Rectangle 15"/>
+            <a:pPr algn="l"/>
+            <a:r>
+              <a:rPr sz="800" b="0">
+                <a:solidFill>
+                  <a:srgbClr val="8A95A5"/>
+                </a:solidFill>
+                <a:latin typeface="Calibri"/>
+              </a:rPr>
+              <a:t>Lectura → validación → consulta SII → clasificación → persistencia → cuarentena</a:t>
+            </a:r>
+          </a:p>
+        </p:txBody>
+      </p:sp>
+      <p:sp>
+        <p:nvSpPr>
+          <p:cNvPr id="45" name="Rounded Rectangle 44"/>
           <p:cNvSpPr/>
           <p:nvPr/>
         </p:nvSpPr>
         <p:spPr>
           <a:xfrm>
-            <a:off x="731520" y="3840480"/>
-            <a:ext cx="5303520" cy="777240"/>
+            <a:off x="731520" y="3040000"/>
+            <a:ext cx="5000000" cy="500000"/>
           </a:xfrm>
           <a:prstGeom prst="roundRect">
             <a:avLst/>
           </a:prstGeom>
           <a:solidFill>
-            <a:srgbClr val="FFFFFF"/>
+            <a:srgbClr val="F0F2F5"/>
           </a:solidFill>
-          <a:ln w="12700">
-            <a:solidFill>
-              <a:srgbClr val="D0DEED"/>
-            </a:solidFill>
+          <a:ln>
+            <a:noFill/>
           </a:ln>
-          <a:effectLst/>
         </p:spPr>
         <p:style>
           <a:lnRef idx="1">
@@ -11897,31 +11907,29 @@
           <a:lstStyle/>
           <a:p>
             <a:pPr algn="ctr"/>
-            <a:endParaRPr/>
-          </a:p>
-        </p:txBody>
-      </p:sp>
-      <p:sp>
-        <p:nvSpPr>
-          <p:cNvPr id="17" name="Rectangle 16"/>
+          </a:p>
+        </p:txBody>
+      </p:sp>
+      <p:sp>
+        <p:nvSpPr>
+          <p:cNvPr id="46" name="Rectangle 45"/>
           <p:cNvSpPr/>
           <p:nvPr/>
         </p:nvSpPr>
         <p:spPr>
           <a:xfrm>
-            <a:off x="731520" y="3840480"/>
-            <a:ext cx="54864" cy="777240"/>
+            <a:off x="731520" y="3040000"/>
+            <a:ext cx="45720" cy="500000"/>
           </a:xfrm>
           <a:prstGeom prst="rect">
             <a:avLst/>
           </a:prstGeom>
           <a:solidFill>
-            <a:srgbClr val="38A169"/>
+            <a:srgbClr val="2ECC71"/>
           </a:solidFill>
           <a:ln>
             <a:noFill/>
           </a:ln>
-          <a:effectLst/>
         </p:spPr>
         <p:style>
           <a:lnRef idx="1">
@@ -11942,31 +11950,29 @@
           <a:lstStyle/>
           <a:p>
             <a:pPr algn="ctr"/>
-            <a:endParaRPr/>
-          </a:p>
-        </p:txBody>
-      </p:sp>
-      <p:sp>
-        <p:nvSpPr>
-          <p:cNvPr id="18" name="Oval 17"/>
+          </a:p>
+        </p:txBody>
+      </p:sp>
+      <p:sp>
+        <p:nvSpPr>
+          <p:cNvPr id="47" name="Oval 46"/>
           <p:cNvSpPr/>
           <p:nvPr/>
         </p:nvSpPr>
         <p:spPr>
           <a:xfrm>
-            <a:off x="960120" y="4041648"/>
-            <a:ext cx="365760" cy="365760"/>
+            <a:off x="851520" y="3140000"/>
+            <a:ext cx="280000" cy="280000"/>
           </a:xfrm>
           <a:prstGeom prst="ellipse">
             <a:avLst/>
           </a:prstGeom>
           <a:solidFill>
-            <a:srgbClr val="38A169"/>
+            <a:srgbClr val="2ECC71"/>
           </a:solidFill>
           <a:ln>
             <a:noFill/>
           </a:ln>
-          <a:effectLst/>
         </p:spPr>
         <p:style>
           <a:lnRef idx="1">
@@ -11986,30 +11992,28 @@
           <a:bodyPr rtlCol="0" anchor="ctr"/>
           <a:lstStyle/>
           <a:p>
-            <a:pPr algn="ctr">
-              <a:defRPr sz="1000" b="1">
+            <a:pPr algn="ctr"/>
+            <a:r>
+              <a:rPr sz="1000" b="1">
                 <a:solidFill>
                   <a:srgbClr val="FFFFFF"/>
                 </a:solidFill>
-                <a:latin typeface="Calibri"/>
-              </a:defRPr>
-            </a:pPr>
-            <a:r>
-              <a:t>ok</a:t>
-            </a:r>
-          </a:p>
-        </p:txBody>
-      </p:sp>
-      <p:sp>
-        <p:nvSpPr>
-          <p:cNvPr id="19" name="TextBox 18"/>
+              </a:rPr>
+              <a:t>✓</a:t>
+            </a:r>
+          </a:p>
+        </p:txBody>
+      </p:sp>
+      <p:sp>
+        <p:nvSpPr>
+          <p:cNvPr id="48" name="TextBox 47"/>
           <p:cNvSpPr txBox="1"/>
           <p:nvPr/>
         </p:nvSpPr>
         <p:spPr>
           <a:xfrm>
-            <a:off x="1463040" y="3913632"/>
-            <a:ext cx="4389120" cy="320040"/>
+            <a:off x="1231520" y="3085000"/>
+            <a:ext cx="4300000" cy="200000"/>
           </a:xfrm>
           <a:prstGeom prst="rect">
             <a:avLst/>
@@ -12022,15 +12026,14 @@
           </a:bodyPr>
           <a:lstStyle/>
           <a:p>
-            <a:pPr algn="l">
-              <a:defRPr sz="1400" b="1">
-                <a:solidFill>
-                  <a:srgbClr val="1B3A5C"/>
-                </a:solidFill>
-                <a:latin typeface="Calibri"/>
-              </a:defRPr>
-            </a:pPr>
-            <a:r>
+            <a:pPr algn="l"/>
+            <a:r>
+              <a:rPr sz="1100" b="1">
+                <a:solidFill>
+                  <a:srgbClr val="1B2A4A"/>
+                </a:solidFill>
+                <a:latin typeface="Calibri"/>
+              </a:rPr>
               <a:t>Diccionario de datos</a:t>
             </a:r>
           </a:p>
@@ -12038,14 +12041,14 @@
       </p:sp>
       <p:sp>
         <p:nvSpPr>
-          <p:cNvPr id="20" name="TextBox 19"/>
+          <p:cNvPr id="49" name="TextBox 48"/>
           <p:cNvSpPr txBox="1"/>
           <p:nvPr/>
         </p:nvSpPr>
         <p:spPr>
           <a:xfrm>
-            <a:off x="1463040" y="4251960"/>
-            <a:ext cx="4389120" cy="320040"/>
+            <a:off x="1231520" y="3300000"/>
+            <a:ext cx="4300000" cy="200000"/>
           </a:xfrm>
           <a:prstGeom prst="rect">
             <a:avLst/>
@@ -12058,15 +12061,14 @@
           </a:bodyPr>
           <a:lstStyle/>
           <a:p>
-            <a:pPr algn="l">
-              <a:defRPr sz="1100" b="0">
-                <a:solidFill>
-                  <a:srgbClr val="4A5568"/>
-                </a:solidFill>
-                <a:latin typeface="Calibri"/>
-              </a:defRPr>
-            </a:pPr>
-            <a:r>
+            <a:pPr algn="l"/>
+            <a:r>
+              <a:rPr sz="800" b="0">
+                <a:solidFill>
+                  <a:srgbClr val="8A95A5"/>
+                </a:solidFill>
+                <a:latin typeface="Calibri"/>
+              </a:rPr>
               <a:t>Grano, columnas, claves y reglas de calidad por cada archivo CSV</a:t>
             </a:r>
           </a:p>
@@ -12074,27 +12076,24 @@
       </p:sp>
       <p:sp>
         <p:nvSpPr>
-          <p:cNvPr id="21" name="Rounded Rectangle 20"/>
+          <p:cNvPr id="50" name="Rounded Rectangle 49"/>
           <p:cNvSpPr/>
           <p:nvPr/>
         </p:nvSpPr>
         <p:spPr>
           <a:xfrm>
-            <a:off x="731520" y="4709160"/>
-            <a:ext cx="5303520" cy="777240"/>
+            <a:off x="731520" y="3600000"/>
+            <a:ext cx="5000000" cy="500000"/>
           </a:xfrm>
           <a:prstGeom prst="roundRect">
             <a:avLst/>
           </a:prstGeom>
           <a:solidFill>
-            <a:srgbClr val="FFFFFF"/>
+            <a:srgbClr val="F0F2F5"/>
           </a:solidFill>
-          <a:ln w="12700">
-            <a:solidFill>
-              <a:srgbClr val="D0DEED"/>
-            </a:solidFill>
+          <a:ln>
+            <a:noFill/>
           </a:ln>
-          <a:effectLst/>
         </p:spPr>
         <p:style>
           <a:lnRef idx="1">
@@ -12115,31 +12114,29 @@
           <a:lstStyle/>
           <a:p>
             <a:pPr algn="ctr"/>
-            <a:endParaRPr/>
-          </a:p>
-        </p:txBody>
-      </p:sp>
-      <p:sp>
-        <p:nvSpPr>
-          <p:cNvPr id="22" name="Rectangle 21"/>
+          </a:p>
+        </p:txBody>
+      </p:sp>
+      <p:sp>
+        <p:nvSpPr>
+          <p:cNvPr id="51" name="Rectangle 50"/>
           <p:cNvSpPr/>
           <p:nvPr/>
         </p:nvSpPr>
         <p:spPr>
           <a:xfrm>
-            <a:off x="731520" y="4709160"/>
-            <a:ext cx="54864" cy="777240"/>
+            <a:off x="731520" y="3600000"/>
+            <a:ext cx="45720" cy="500000"/>
           </a:xfrm>
           <a:prstGeom prst="rect">
             <a:avLst/>
           </a:prstGeom>
           <a:solidFill>
-            <a:srgbClr val="38A169"/>
+            <a:srgbClr val="2ECC71"/>
           </a:solidFill>
           <a:ln>
             <a:noFill/>
           </a:ln>
-          <a:effectLst/>
         </p:spPr>
         <p:style>
           <a:lnRef idx="1">
@@ -12160,31 +12157,29 @@
           <a:lstStyle/>
           <a:p>
             <a:pPr algn="ctr"/>
-            <a:endParaRPr/>
-          </a:p>
-        </p:txBody>
-      </p:sp>
-      <p:sp>
-        <p:nvSpPr>
-          <p:cNvPr id="23" name="Oval 22"/>
+          </a:p>
+        </p:txBody>
+      </p:sp>
+      <p:sp>
+        <p:nvSpPr>
+          <p:cNvPr id="52" name="Oval 51"/>
           <p:cNvSpPr/>
           <p:nvPr/>
         </p:nvSpPr>
         <p:spPr>
           <a:xfrm>
-            <a:off x="960120" y="4910328"/>
-            <a:ext cx="365760" cy="365760"/>
+            <a:off x="851520" y="3700000"/>
+            <a:ext cx="280000" cy="280000"/>
           </a:xfrm>
           <a:prstGeom prst="ellipse">
             <a:avLst/>
           </a:prstGeom>
           <a:solidFill>
-            <a:srgbClr val="38A169"/>
+            <a:srgbClr val="2ECC71"/>
           </a:solidFill>
           <a:ln>
             <a:noFill/>
           </a:ln>
-          <a:effectLst/>
         </p:spPr>
         <p:style>
           <a:lnRef idx="1">
@@ -12204,30 +12199,28 @@
           <a:bodyPr rtlCol="0" anchor="ctr"/>
           <a:lstStyle/>
           <a:p>
-            <a:pPr algn="ctr">
-              <a:defRPr sz="1000" b="1">
+            <a:pPr algn="ctr"/>
+            <a:r>
+              <a:rPr sz="1000" b="1">
                 <a:solidFill>
                   <a:srgbClr val="FFFFFF"/>
                 </a:solidFill>
-                <a:latin typeface="Calibri"/>
-              </a:defRPr>
-            </a:pPr>
-            <a:r>
-              <a:t>ok</a:t>
-            </a:r>
-          </a:p>
-        </p:txBody>
-      </p:sp>
-      <p:sp>
-        <p:nvSpPr>
-          <p:cNvPr id="24" name="TextBox 23"/>
+              </a:rPr>
+              <a:t>✓</a:t>
+            </a:r>
+          </a:p>
+        </p:txBody>
+      </p:sp>
+      <p:sp>
+        <p:nvSpPr>
+          <p:cNvPr id="53" name="TextBox 52"/>
           <p:cNvSpPr txBox="1"/>
           <p:nvPr/>
         </p:nvSpPr>
         <p:spPr>
           <a:xfrm>
-            <a:off x="1463040" y="4782312"/>
-            <a:ext cx="4389120" cy="320040"/>
+            <a:off x="1231520" y="3645000"/>
+            <a:ext cx="4300000" cy="200000"/>
           </a:xfrm>
           <a:prstGeom prst="rect">
             <a:avLst/>
@@ -12240,15 +12233,14 @@
           </a:bodyPr>
           <a:lstStyle/>
           <a:p>
-            <a:pPr algn="l">
-              <a:defRPr sz="1400" b="1">
-                <a:solidFill>
-                  <a:srgbClr val="1B3A5C"/>
-                </a:solidFill>
-                <a:latin typeface="Calibri"/>
-              </a:defRPr>
-            </a:pPr>
-            <a:r>
+            <a:pPr algn="l"/>
+            <a:r>
+              <a:rPr sz="1100" b="1">
+                <a:solidFill>
+                  <a:srgbClr val="1B2A4A"/>
+                </a:solidFill>
+                <a:latin typeface="Calibri"/>
+              </a:rPr>
               <a:t>Demo en vivo</a:t>
             </a:r>
           </a:p>
@@ -12256,14 +12248,14 @@
       </p:sp>
       <p:sp>
         <p:nvSpPr>
-          <p:cNvPr id="25" name="TextBox 24"/>
+          <p:cNvPr id="54" name="TextBox 53"/>
           <p:cNvSpPr txBox="1"/>
           <p:nvPr/>
         </p:nvSpPr>
         <p:spPr>
           <a:xfrm>
-            <a:off x="1463040" y="5120640"/>
-            <a:ext cx="4389120" cy="320040"/>
+            <a:off x="1231520" y="3860000"/>
+            <a:ext cx="4300000" cy="200000"/>
           </a:xfrm>
           <a:prstGeom prst="rect">
             <a:avLst/>
@@ -12276,15 +12268,14 @@
           </a:bodyPr>
           <a:lstStyle/>
           <a:p>
-            <a:pPr algn="l">
-              <a:defRPr sz="1100" b="0">
-                <a:solidFill>
-                  <a:srgbClr val="4A5568"/>
-                </a:solidFill>
-                <a:latin typeface="Calibri"/>
-              </a:defRPr>
-            </a:pPr>
-            <a:r>
+            <a:pPr algn="l"/>
+            <a:r>
+              <a:rPr sz="800" b="0">
+                <a:solidFill>
+                  <a:srgbClr val="8A95A5"/>
+                </a:solidFill>
+                <a:latin typeface="Calibri"/>
+              </a:rPr>
               <a:t>Caso Contador + PYME + Cuarentena + Multi-giro</a:t>
             </a:r>
           </a:p>
@@ -12292,27 +12283,24 @@
       </p:sp>
       <p:sp>
         <p:nvSpPr>
-          <p:cNvPr id="26" name="Rounded Rectangle 25"/>
+          <p:cNvPr id="55" name="Rounded Rectangle 54"/>
           <p:cNvSpPr/>
           <p:nvPr/>
         </p:nvSpPr>
         <p:spPr>
           <a:xfrm>
-            <a:off x="731520" y="5577840"/>
-            <a:ext cx="5303520" cy="777240"/>
+            <a:off x="731520" y="4160000"/>
+            <a:ext cx="5000000" cy="500000"/>
           </a:xfrm>
           <a:prstGeom prst="roundRect">
             <a:avLst/>
           </a:prstGeom>
           <a:solidFill>
-            <a:srgbClr val="FFFFFF"/>
+            <a:srgbClr val="F0F2F5"/>
           </a:solidFill>
-          <a:ln w="12700">
-            <a:solidFill>
-              <a:srgbClr val="D0DEED"/>
-            </a:solidFill>
+          <a:ln>
+            <a:noFill/>
           </a:ln>
-          <a:effectLst/>
         </p:spPr>
         <p:style>
           <a:lnRef idx="1">
@@ -12333,31 +12321,29 @@
           <a:lstStyle/>
           <a:p>
             <a:pPr algn="ctr"/>
-            <a:endParaRPr/>
-          </a:p>
-        </p:txBody>
-      </p:sp>
-      <p:sp>
-        <p:nvSpPr>
-          <p:cNvPr id="27" name="Rectangle 26"/>
+          </a:p>
+        </p:txBody>
+      </p:sp>
+      <p:sp>
+        <p:nvSpPr>
+          <p:cNvPr id="56" name="Rectangle 55"/>
           <p:cNvSpPr/>
           <p:nvPr/>
         </p:nvSpPr>
         <p:spPr>
           <a:xfrm>
-            <a:off x="731520" y="5577840"/>
-            <a:ext cx="54864" cy="777240"/>
+            <a:off x="731520" y="4160000"/>
+            <a:ext cx="45720" cy="500000"/>
           </a:xfrm>
           <a:prstGeom prst="rect">
             <a:avLst/>
           </a:prstGeom>
           <a:solidFill>
-            <a:srgbClr val="38A169"/>
+            <a:srgbClr val="2ECC71"/>
           </a:solidFill>
           <a:ln>
             <a:noFill/>
           </a:ln>
-          <a:effectLst/>
         </p:spPr>
         <p:style>
           <a:lnRef idx="1">
@@ -12378,31 +12364,29 @@
           <a:lstStyle/>
           <a:p>
             <a:pPr algn="ctr"/>
-            <a:endParaRPr/>
-          </a:p>
-        </p:txBody>
-      </p:sp>
-      <p:sp>
-        <p:nvSpPr>
-          <p:cNvPr id="28" name="Oval 27"/>
+          </a:p>
+        </p:txBody>
+      </p:sp>
+      <p:sp>
+        <p:nvSpPr>
+          <p:cNvPr id="57" name="Oval 56"/>
           <p:cNvSpPr/>
           <p:nvPr/>
         </p:nvSpPr>
         <p:spPr>
           <a:xfrm>
-            <a:off x="960120" y="5779008"/>
-            <a:ext cx="365760" cy="365760"/>
+            <a:off x="851520" y="4260000"/>
+            <a:ext cx="280000" cy="280000"/>
           </a:xfrm>
           <a:prstGeom prst="ellipse">
             <a:avLst/>
           </a:prstGeom>
           <a:solidFill>
-            <a:srgbClr val="38A169"/>
+            <a:srgbClr val="2ECC71"/>
           </a:solidFill>
           <a:ln>
             <a:noFill/>
           </a:ln>
-          <a:effectLst/>
         </p:spPr>
         <p:style>
           <a:lnRef idx="1">
@@ -12422,30 +12406,28 @@
           <a:bodyPr rtlCol="0" anchor="ctr"/>
           <a:lstStyle/>
           <a:p>
-            <a:pPr algn="ctr">
-              <a:defRPr sz="1000" b="1">
+            <a:pPr algn="ctr"/>
+            <a:r>
+              <a:rPr sz="1000" b="1">
                 <a:solidFill>
                   <a:srgbClr val="FFFFFF"/>
                 </a:solidFill>
-                <a:latin typeface="Calibri"/>
-              </a:defRPr>
-            </a:pPr>
-            <a:r>
-              <a:t>ok</a:t>
-            </a:r>
-          </a:p>
-        </p:txBody>
-      </p:sp>
-      <p:sp>
-        <p:nvSpPr>
-          <p:cNvPr id="29" name="TextBox 28"/>
+              </a:rPr>
+              <a:t>✓</a:t>
+            </a:r>
+          </a:p>
+        </p:txBody>
+      </p:sp>
+      <p:sp>
+        <p:nvSpPr>
+          <p:cNvPr id="58" name="TextBox 57"/>
           <p:cNvSpPr txBox="1"/>
           <p:nvPr/>
         </p:nvSpPr>
         <p:spPr>
           <a:xfrm>
-            <a:off x="1463040" y="5650992"/>
-            <a:ext cx="4389120" cy="320040"/>
+            <a:off x="1231520" y="4205000"/>
+            <a:ext cx="4300000" cy="200000"/>
           </a:xfrm>
           <a:prstGeom prst="rect">
             <a:avLst/>
@@ -12458,15 +12440,14 @@
           </a:bodyPr>
           <a:lstStyle/>
           <a:p>
-            <a:pPr algn="l">
-              <a:defRPr sz="1400" b="1">
-                <a:solidFill>
-                  <a:srgbClr val="1B3A5C"/>
-                </a:solidFill>
-                <a:latin typeface="Calibri"/>
-              </a:defRPr>
-            </a:pPr>
-            <a:r>
+            <a:pPr algn="l"/>
+            <a:r>
+              <a:rPr sz="1100" b="1">
+                <a:solidFill>
+                  <a:srgbClr val="1B2A4A"/>
+                </a:solidFill>
+                <a:latin typeface="Calibri"/>
+              </a:rPr>
               <a:t>Diagrama en la nube</a:t>
             </a:r>
           </a:p>
@@ -12474,14 +12455,14 @@
       </p:sp>
       <p:sp>
         <p:nvSpPr>
-          <p:cNvPr id="30" name="TextBox 29"/>
+          <p:cNvPr id="59" name="TextBox 58"/>
           <p:cNvSpPr txBox="1"/>
           <p:nvPr/>
         </p:nvSpPr>
         <p:spPr>
           <a:xfrm>
-            <a:off x="1463040" y="5989320"/>
-            <a:ext cx="4389120" cy="320040"/>
+            <a:off x="1231520" y="4420000"/>
+            <a:ext cx="4300000" cy="200000"/>
           </a:xfrm>
           <a:prstGeom prst="rect">
             <a:avLst/>
@@ -12494,15 +12475,14 @@
           </a:bodyPr>
           <a:lstStyle/>
           <a:p>
-            <a:pPr algn="l">
-              <a:defRPr sz="1100" b="0">
-                <a:solidFill>
-                  <a:srgbClr val="4A5568"/>
-                </a:solidFill>
-                <a:latin typeface="Calibri"/>
-              </a:defRPr>
-            </a:pPr>
-            <a:r>
+            <a:pPr algn="l"/>
+            <a:r>
+              <a:rPr sz="800" b="0">
+                <a:solidFill>
+                  <a:srgbClr val="8A95A5"/>
+                </a:solidFill>
+                <a:latin typeface="Calibri"/>
+              </a:rPr>
               <a:t>Step Functions + ECS Fargate + S3 + Athena + CloudWatch (AWS)</a:t>
             </a:r>
           </a:p>
@@ -12510,25 +12490,24 @@
       </p:sp>
       <p:sp>
         <p:nvSpPr>
-          <p:cNvPr id="31" name="Rounded Rectangle 30"/>
+          <p:cNvPr id="60" name="Rounded Rectangle 59"/>
           <p:cNvSpPr/>
           <p:nvPr/>
         </p:nvSpPr>
         <p:spPr>
           <a:xfrm>
-            <a:off x="6492240" y="1554480"/>
-            <a:ext cx="4937760" cy="4846320"/>
+            <a:off x="6200000" y="1554480"/>
+            <a:ext cx="5500000" cy="4900000"/>
           </a:xfrm>
           <a:prstGeom prst="roundRect">
             <a:avLst/>
           </a:prstGeom>
           <a:solidFill>
-            <a:srgbClr val="1B3A5C"/>
+            <a:srgbClr val="1B2A4A"/>
           </a:solidFill>
           <a:ln>
             <a:noFill/>
           </a:ln>
-          <a:effectLst/>
         </p:spPr>
         <p:style>
           <a:lnRef idx="1">
@@ -12549,20 +12528,19 @@
           <a:lstStyle/>
           <a:p>
             <a:pPr algn="ctr"/>
-            <a:endParaRPr/>
-          </a:p>
-        </p:txBody>
-      </p:sp>
-      <p:sp>
-        <p:nvSpPr>
-          <p:cNvPr id="32" name="TextBox 31"/>
+          </a:p>
+        </p:txBody>
+      </p:sp>
+      <p:sp>
+        <p:nvSpPr>
+          <p:cNvPr id="61" name="TextBox 60"/>
           <p:cNvSpPr txBox="1"/>
           <p:nvPr/>
         </p:nvSpPr>
         <p:spPr>
           <a:xfrm>
-            <a:off x="6858000" y="1737360"/>
-            <a:ext cx="4389120" cy="4572000"/>
+            <a:off x="6550000" y="1734480"/>
+            <a:ext cx="4800000" cy="400000"/>
           </a:xfrm>
           <a:prstGeom prst="rect">
             <a:avLst/>
@@ -12575,479 +12553,72 @@
           </a:bodyPr>
           <a:lstStyle/>
           <a:p>
-            <a:pPr algn="l">
-              <a:spcAft>
-                <a:spcPts val="2000"/>
-              </a:spcAft>
-              <a:defRPr sz="2000" b="1">
+            <a:pPr algn="l"/>
+            <a:r>
+              <a:rPr sz="2000" b="1">
                 <a:solidFill>
                   <a:srgbClr val="FFFFFF"/>
                 </a:solidFill>
                 <a:latin typeface="Calibri"/>
-              </a:defRPr>
-            </a:pPr>
-            <a:r>
-              <a:rPr dirty="0"/>
-              <a:t>Bonus </a:t>
-            </a:r>
-            <a:r>
-              <a:rPr dirty="0" err="1"/>
-              <a:t>implementados</a:t>
-            </a:r>
-            <a:endParaRPr dirty="0"/>
-          </a:p>
-          <a:p>
-            <a:pPr algn="l">
-              <a:spcAft>
-                <a:spcPts val="400"/>
-              </a:spcAft>
-              <a:defRPr sz="1500" b="1">
-                <a:solidFill>
-                  <a:srgbClr val="68D391"/>
-                </a:solidFill>
-                <a:latin typeface="Calibri"/>
-              </a:defRPr>
-            </a:pPr>
-            <a:r>
-              <a:rPr dirty="0" err="1"/>
-              <a:t>Migracion</a:t>
-            </a:r>
-            <a:r>
-              <a:rPr dirty="0"/>
-              <a:t> a </a:t>
-            </a:r>
-            <a:r>
-              <a:rPr dirty="0" err="1"/>
-              <a:t>asyncio</a:t>
-            </a:r>
-            <a:endParaRPr dirty="0"/>
-          </a:p>
-          <a:p>
-            <a:pPr algn="l">
-              <a:spcAft>
-                <a:spcPts val="1600"/>
-              </a:spcAft>
-              <a:defRPr sz="1200" b="0">
-                <a:solidFill>
-                  <a:srgbClr val="A0C4E8"/>
-                </a:solidFill>
-                <a:latin typeface="Calibri"/>
-              </a:defRPr>
-            </a:pPr>
-            <a:r>
-              <a:rPr dirty="0"/>
-              <a:t>+60% </a:t>
-            </a:r>
-            <a:r>
-              <a:rPr dirty="0" err="1"/>
-              <a:t>velocidad</a:t>
-            </a:r>
-            <a:r>
-              <a:rPr dirty="0"/>
-              <a:t> con </a:t>
-            </a:r>
-            <a:r>
-              <a:rPr dirty="0" err="1"/>
-              <a:t>Semaforo</a:t>
-            </a:r>
-            <a:r>
-              <a:rPr dirty="0"/>
-              <a:t> de </a:t>
-            </a:r>
-            <a:r>
-              <a:rPr dirty="0" err="1"/>
-              <a:t>concurrencia</a:t>
-            </a:r>
-            <a:endParaRPr dirty="0"/>
-          </a:p>
-          <a:p>
-            <a:pPr algn="l">
-              <a:spcAft>
-                <a:spcPts val="400"/>
-              </a:spcAft>
-              <a:defRPr sz="1500" b="1">
-                <a:solidFill>
-                  <a:srgbClr val="68D391"/>
-                </a:solidFill>
-                <a:latin typeface="Calibri"/>
-              </a:defRPr>
-            </a:pPr>
-            <a:r>
-              <a:rPr dirty="0"/>
-              <a:t>Evasion WAF</a:t>
-            </a:r>
-          </a:p>
-          <a:p>
-            <a:pPr algn="l">
-              <a:spcAft>
-                <a:spcPts val="1600"/>
-              </a:spcAft>
-              <a:defRPr sz="1200" b="0">
-                <a:solidFill>
-                  <a:srgbClr val="A0C4E8"/>
-                </a:solidFill>
-                <a:latin typeface="Calibri"/>
-              </a:defRPr>
-            </a:pPr>
-            <a:r>
-              <a:rPr dirty="0"/>
-              <a:t>Stealth (</a:t>
-            </a:r>
-            <a:r>
-              <a:rPr dirty="0" err="1"/>
-              <a:t>ocultar</a:t>
-            </a:r>
-            <a:r>
-              <a:rPr dirty="0"/>
-              <a:t> </a:t>
-            </a:r>
-            <a:r>
-              <a:rPr dirty="0" err="1"/>
-              <a:t>webdriver</a:t>
-            </a:r>
-            <a:r>
-              <a:rPr dirty="0"/>
-              <a:t>) + Jitter (delays </a:t>
-            </a:r>
-            <a:r>
-              <a:rPr dirty="0" err="1"/>
-              <a:t>aleatorios</a:t>
-            </a:r>
-            <a:r>
-              <a:rPr dirty="0"/>
-              <a:t>)</a:t>
-            </a:r>
-          </a:p>
-          <a:p>
-            <a:pPr algn="l">
-              <a:spcAft>
-                <a:spcPts val="400"/>
-              </a:spcAft>
-              <a:defRPr sz="1500" b="1">
-                <a:solidFill>
-                  <a:srgbClr val="68D391"/>
-                </a:solidFill>
-                <a:latin typeface="Calibri"/>
-              </a:defRPr>
-            </a:pPr>
-            <a:r>
-              <a:rPr dirty="0"/>
-              <a:t>41 Tests </a:t>
-            </a:r>
-            <a:r>
-              <a:rPr dirty="0" err="1"/>
-              <a:t>Unitarios</a:t>
-            </a:r>
-            <a:endParaRPr dirty="0"/>
-          </a:p>
-          <a:p>
-            <a:pPr algn="l">
-              <a:spcAft>
-                <a:spcPts val="1600"/>
-              </a:spcAft>
-              <a:defRPr sz="1200" b="0">
-                <a:solidFill>
-                  <a:srgbClr val="A0C4E8"/>
-                </a:solidFill>
-                <a:latin typeface="Calibri"/>
-              </a:defRPr>
-            </a:pPr>
-            <a:r>
-              <a:rPr dirty="0"/>
-              <a:t>100% </a:t>
-            </a:r>
-            <a:r>
-              <a:rPr dirty="0" err="1"/>
-              <a:t>cobertura</a:t>
-            </a:r>
-            <a:r>
-              <a:rPr dirty="0"/>
-              <a:t> de </a:t>
-            </a:r>
-            <a:r>
-              <a:rPr dirty="0" err="1"/>
-              <a:t>logica</a:t>
-            </a:r>
-            <a:r>
-              <a:rPr dirty="0"/>
-              <a:t> </a:t>
-            </a:r>
-            <a:r>
-              <a:rPr dirty="0" err="1"/>
-              <a:t>sincrona</a:t>
-            </a:r>
-            <a:r>
-              <a:rPr dirty="0"/>
-              <a:t> con </a:t>
-            </a:r>
-            <a:r>
-              <a:rPr dirty="0" err="1"/>
-              <a:t>pytest</a:t>
-            </a:r>
-            <a:endParaRPr dirty="0"/>
-          </a:p>
-          <a:p>
-            <a:pPr algn="l">
-              <a:spcAft>
-                <a:spcPts val="400"/>
-              </a:spcAft>
-              <a:defRPr sz="1500" b="1">
-                <a:solidFill>
-                  <a:srgbClr val="68D391"/>
-                </a:solidFill>
-                <a:latin typeface="Calibri"/>
-              </a:defRPr>
-            </a:pPr>
-            <a:r>
-              <a:rPr dirty="0"/>
-              <a:t>Backoff </a:t>
-            </a:r>
-            <a:r>
-              <a:rPr dirty="0" err="1"/>
-              <a:t>Exponencial</a:t>
-            </a:r>
-            <a:endParaRPr dirty="0"/>
-          </a:p>
-          <a:p>
-            <a:pPr algn="l">
-              <a:spcAft>
-                <a:spcPts val="2400"/>
-              </a:spcAft>
-              <a:defRPr sz="1200" b="0">
-                <a:solidFill>
-                  <a:srgbClr val="A0C4E8"/>
-                </a:solidFill>
-                <a:latin typeface="Calibri"/>
-              </a:defRPr>
-            </a:pPr>
-            <a:r>
-              <a:rPr dirty="0"/>
-              <a:t>Retries </a:t>
-            </a:r>
-            <a:r>
-              <a:rPr dirty="0" err="1"/>
-              <a:t>automaticos</a:t>
-            </a:r>
-            <a:r>
-              <a:rPr dirty="0"/>
-              <a:t> (2s, 4s, 8s) con tenacity</a:t>
-            </a:r>
-          </a:p>
-          <a:p>
-            <a:pPr algn="l">
-              <a:spcAft>
-                <a:spcPts val="1200"/>
-              </a:spcAft>
-              <a:defRPr sz="1200" b="0">
-                <a:solidFill>
-                  <a:srgbClr val="4A5E78"/>
-                </a:solidFill>
-                <a:latin typeface="Calibri"/>
-              </a:defRPr>
-            </a:pPr>
-            <a:r>
-              <a:rPr dirty="0"/>
-              <a:t>---</a:t>
-            </a:r>
-          </a:p>
-          <a:p>
-            <a:pPr algn="l">
-              <a:spcAft>
-                <a:spcPts val="800"/>
-              </a:spcAft>
-              <a:defRPr sz="1400" b="1">
-                <a:solidFill>
-                  <a:srgbClr val="E8612D"/>
-                </a:solidFill>
-                <a:latin typeface="Calibri"/>
-              </a:defRPr>
-            </a:pPr>
-            <a:r>
-              <a:rPr dirty="0" err="1"/>
-              <a:t>Criterio</a:t>
-            </a:r>
-            <a:r>
-              <a:rPr dirty="0"/>
-              <a:t> </a:t>
-            </a:r>
-            <a:r>
-              <a:rPr dirty="0" err="1"/>
-              <a:t>aplicado</a:t>
-            </a:r>
-            <a:r>
-              <a:rPr dirty="0"/>
-              <a:t>:</a:t>
-            </a:r>
-          </a:p>
-          <a:p>
-            <a:pPr algn="l">
-              <a:spcAft>
-                <a:spcPts val="200"/>
-              </a:spcAft>
-              <a:defRPr sz="1200" b="0">
-                <a:solidFill>
-                  <a:srgbClr val="A0C4E8"/>
-                </a:solidFill>
-                <a:latin typeface="Calibri"/>
-              </a:defRPr>
-            </a:pPr>
-            <a:r>
-              <a:rPr dirty="0"/>
-              <a:t>"No hay </a:t>
-            </a:r>
-            <a:r>
-              <a:rPr dirty="0" err="1"/>
-              <a:t>una</a:t>
-            </a:r>
-            <a:r>
-              <a:rPr dirty="0"/>
-              <a:t> unica </a:t>
-            </a:r>
-            <a:r>
-              <a:rPr dirty="0" err="1"/>
-              <a:t>solucion</a:t>
-            </a:r>
-            <a:r>
-              <a:rPr dirty="0"/>
-              <a:t> </a:t>
-            </a:r>
-            <a:r>
-              <a:rPr dirty="0" err="1"/>
-              <a:t>correcta</a:t>
-            </a:r>
-            <a:r>
-              <a:rPr dirty="0"/>
-              <a:t>.</a:t>
-            </a:r>
-          </a:p>
-          <a:p>
-            <a:pPr algn="l">
-              <a:spcAft>
-                <a:spcPts val="200"/>
-              </a:spcAft>
-              <a:defRPr sz="1200" b="0">
-                <a:solidFill>
-                  <a:srgbClr val="A0C4E8"/>
-                </a:solidFill>
-                <a:latin typeface="Calibri"/>
-              </a:defRPr>
-            </a:pPr>
-            <a:r>
-              <a:rPr dirty="0"/>
-              <a:t>Lo </a:t>
-            </a:r>
-            <a:r>
-              <a:rPr dirty="0" err="1"/>
-              <a:t>que</a:t>
-            </a:r>
-            <a:r>
-              <a:rPr dirty="0"/>
-              <a:t> </a:t>
-            </a:r>
-            <a:r>
-              <a:rPr dirty="0" err="1"/>
-              <a:t>importa</a:t>
-            </a:r>
-            <a:r>
-              <a:rPr dirty="0"/>
-              <a:t> es </a:t>
-            </a:r>
-            <a:r>
-              <a:rPr dirty="0" err="1"/>
-              <a:t>como</a:t>
-            </a:r>
-            <a:r>
-              <a:rPr dirty="0"/>
-              <a:t> </a:t>
-            </a:r>
-            <a:r>
-              <a:rPr dirty="0" err="1"/>
-              <a:t>piensas</a:t>
-            </a:r>
-            <a:r>
-              <a:rPr dirty="0"/>
-              <a:t>,</a:t>
-            </a:r>
-          </a:p>
-          <a:p>
-            <a:pPr algn="l">
-              <a:spcAft>
-                <a:spcPts val="200"/>
-              </a:spcAft>
-              <a:defRPr sz="1200" b="0">
-                <a:solidFill>
-                  <a:srgbClr val="A0C4E8"/>
-                </a:solidFill>
-                <a:latin typeface="Calibri"/>
-              </a:defRPr>
-            </a:pPr>
-            <a:r>
-              <a:rPr dirty="0" err="1"/>
-              <a:t>que</a:t>
-            </a:r>
-            <a:r>
-              <a:rPr dirty="0"/>
-              <a:t> </a:t>
-            </a:r>
-            <a:r>
-              <a:rPr dirty="0" err="1"/>
-              <a:t>priorizaste</a:t>
-            </a:r>
-            <a:r>
-              <a:rPr dirty="0"/>
-              <a:t> y </a:t>
-            </a:r>
-            <a:r>
-              <a:rPr dirty="0" err="1"/>
-              <a:t>que</a:t>
-            </a:r>
-            <a:r>
-              <a:rPr dirty="0"/>
-              <a:t> </a:t>
-            </a:r>
-            <a:r>
-              <a:rPr dirty="0" err="1"/>
-              <a:t>dejaste</a:t>
-            </a:r>
-            <a:r>
-              <a:rPr dirty="0"/>
-              <a:t> fuera</a:t>
-            </a:r>
-          </a:p>
-          <a:p>
-            <a:pPr algn="l">
-              <a:defRPr sz="1200" b="0">
-                <a:solidFill>
-                  <a:srgbClr val="A0C4E8"/>
-                </a:solidFill>
-                <a:latin typeface="Calibri"/>
-              </a:defRPr>
-            </a:pPr>
-            <a:r>
-              <a:rPr dirty="0"/>
-              <a:t>a </a:t>
-            </a:r>
-            <a:r>
-              <a:rPr dirty="0" err="1"/>
-              <a:t>proposito</a:t>
-            </a:r>
-            <a:r>
-              <a:rPr dirty="0"/>
-              <a:t>."</a:t>
-            </a:r>
-          </a:p>
-        </p:txBody>
-      </p:sp>
-      <p:sp>
-        <p:nvSpPr>
-          <p:cNvPr id="33" name="TextBox 32"/>
+              </a:rPr>
+              <a:t>Visión a Futuro</a:t>
+            </a:r>
+          </a:p>
+        </p:txBody>
+      </p:sp>
+      <p:sp>
+        <p:nvSpPr>
+          <p:cNvPr id="62" name="Rectangle 61"/>
+          <p:cNvSpPr/>
+          <p:nvPr/>
+        </p:nvSpPr>
+        <p:spPr>
+          <a:xfrm>
+            <a:off x="6550000" y="2134480"/>
+            <a:ext cx="600000" cy="36000"/>
+          </a:xfrm>
+          <a:prstGeom prst="rect">
+            <a:avLst/>
+          </a:prstGeom>
+          <a:solidFill>
+            <a:srgbClr val="E86C00"/>
+          </a:solidFill>
+          <a:ln>
+            <a:noFill/>
+          </a:ln>
+        </p:spPr>
+        <p:style>
+          <a:lnRef idx="1">
+            <a:schemeClr val="accent1"/>
+          </a:lnRef>
+          <a:fillRef idx="3">
+            <a:schemeClr val="accent1"/>
+          </a:fillRef>
+          <a:effectRef idx="2">
+            <a:schemeClr val="accent1"/>
+          </a:effectRef>
+          <a:fontRef idx="minor">
+            <a:schemeClr val="lt1"/>
+          </a:fontRef>
+        </p:style>
+        <p:txBody>
+          <a:bodyPr rtlCol="0" anchor="ctr"/>
+          <a:lstStyle/>
+          <a:p>
+            <a:pPr algn="ctr"/>
+          </a:p>
+        </p:txBody>
+      </p:sp>
+      <p:sp>
+        <p:nvSpPr>
+          <p:cNvPr id="63" name="TextBox 62"/>
           <p:cNvSpPr txBox="1"/>
           <p:nvPr/>
         </p:nvSpPr>
         <p:spPr>
           <a:xfrm>
-            <a:off x="731520" y="6400800"/>
-            <a:ext cx="10698480" cy="365760"/>
+            <a:off x="6550000" y="2274480"/>
+            <a:ext cx="4800000" cy="300000"/>
           </a:xfrm>
           <a:prstGeom prst="rect">
             <a:avLst/>
@@ -13060,16 +12631,260 @@
           </a:bodyPr>
           <a:lstStyle/>
           <a:p>
-            <a:pPr algn="ctr">
-              <a:defRPr sz="1600" b="1">
-                <a:solidFill>
-                  <a:srgbClr val="1B3A5C"/>
-                </a:solidFill>
-                <a:latin typeface="Calibri"/>
-              </a:defRPr>
-            </a:pPr>
-            <a:r>
-              <a:t>Gracias! Preguntas?  |  Alexis Taha  |  Data Engineer Semi-Senior</a:t>
+            <a:pPr algn="l"/>
+            <a:r>
+              <a:rPr sz="1300" b="1">
+                <a:solidFill>
+                  <a:srgbClr val="E86C00"/>
+                </a:solidFill>
+                <a:latin typeface="Calibri"/>
+              </a:rPr>
+              <a:t>🚀  Entorno Productivo</a:t>
+            </a:r>
+          </a:p>
+        </p:txBody>
+      </p:sp>
+      <p:sp>
+        <p:nvSpPr>
+          <p:cNvPr id="64" name="TextBox 63"/>
+          <p:cNvSpPr txBox="1"/>
+          <p:nvPr/>
+        </p:nvSpPr>
+        <p:spPr>
+          <a:xfrm>
+            <a:off x="6550000" y="2584480"/>
+            <a:ext cx="4800000" cy="600000"/>
+          </a:xfrm>
+          <a:prstGeom prst="rect">
+            <a:avLst/>
+          </a:prstGeom>
+          <a:noFill/>
+        </p:spPr>
+        <p:txBody>
+          <a:bodyPr wrap="square">
+            <a:spAutoFit/>
+          </a:bodyPr>
+          <a:lstStyle/>
+          <a:p>
+            <a:pPr algn="l"/>
+            <a:r>
+              <a:rPr sz="1000" b="0">
+                <a:solidFill>
+                  <a:srgbClr val="CCD0D8"/>
+                </a:solidFill>
+                <a:latin typeface="Calibri"/>
+              </a:rPr>
+              <a:t>Despliegue en AWS con Step Functions orquestando el pipeline completo. Contenedores ECS Fargate para ejecución serverless y escalable.</a:t>
+            </a:r>
+          </a:p>
+        </p:txBody>
+      </p:sp>
+      <p:sp>
+        <p:nvSpPr>
+          <p:cNvPr id="65" name="TextBox 64"/>
+          <p:cNvSpPr txBox="1"/>
+          <p:nvPr/>
+        </p:nvSpPr>
+        <p:spPr>
+          <a:xfrm>
+            <a:off x="6550000" y="3224480"/>
+            <a:ext cx="4800000" cy="300000"/>
+          </a:xfrm>
+          <a:prstGeom prst="rect">
+            <a:avLst/>
+          </a:prstGeom>
+          <a:noFill/>
+        </p:spPr>
+        <p:txBody>
+          <a:bodyPr wrap="square">
+            <a:spAutoFit/>
+          </a:bodyPr>
+          <a:lstStyle/>
+          <a:p>
+            <a:pPr algn="l"/>
+            <a:r>
+              <a:rPr sz="1300" b="1">
+                <a:solidFill>
+                  <a:srgbClr val="E86C00"/>
+                </a:solidFill>
+                <a:latin typeface="Calibri"/>
+              </a:rPr>
+              <a:t>📊  Monitoreo Continuo</a:t>
+            </a:r>
+          </a:p>
+        </p:txBody>
+      </p:sp>
+      <p:sp>
+        <p:nvSpPr>
+          <p:cNvPr id="66" name="TextBox 65"/>
+          <p:cNvSpPr txBox="1"/>
+          <p:nvPr/>
+        </p:nvSpPr>
+        <p:spPr>
+          <a:xfrm>
+            <a:off x="6550000" y="3534480"/>
+            <a:ext cx="4800000" cy="600000"/>
+          </a:xfrm>
+          <a:prstGeom prst="rect">
+            <a:avLst/>
+          </a:prstGeom>
+          <a:noFill/>
+        </p:spPr>
+        <p:txBody>
+          <a:bodyPr wrap="square">
+            <a:spAutoFit/>
+          </a:bodyPr>
+          <a:lstStyle/>
+          <a:p>
+            <a:pPr algn="l"/>
+            <a:r>
+              <a:rPr sz="1000" b="0">
+                <a:solidFill>
+                  <a:srgbClr val="CCD0D8"/>
+                </a:solidFill>
+                <a:latin typeface="Calibri"/>
+              </a:rPr>
+              <a:t>CloudWatch Alarms para tasas de error y latencia. Dashboard en tiempo real con métricas de scraping, clasificación y cuarentena.</a:t>
+            </a:r>
+          </a:p>
+        </p:txBody>
+      </p:sp>
+      <p:sp>
+        <p:nvSpPr>
+          <p:cNvPr id="67" name="TextBox 66"/>
+          <p:cNvSpPr txBox="1"/>
+          <p:nvPr/>
+        </p:nvSpPr>
+        <p:spPr>
+          <a:xfrm>
+            <a:off x="6550000" y="4174480"/>
+            <a:ext cx="4800000" cy="300000"/>
+          </a:xfrm>
+          <a:prstGeom prst="rect">
+            <a:avLst/>
+          </a:prstGeom>
+          <a:noFill/>
+        </p:spPr>
+        <p:txBody>
+          <a:bodyPr wrap="square">
+            <a:spAutoFit/>
+          </a:bodyPr>
+          <a:lstStyle/>
+          <a:p>
+            <a:pPr algn="l"/>
+            <a:r>
+              <a:rPr sz="1300" b="1">
+                <a:solidFill>
+                  <a:srgbClr val="E86C00"/>
+                </a:solidFill>
+                <a:latin typeface="Calibri"/>
+              </a:rPr>
+              <a:t>🔄  Evolución del Pipeline</a:t>
+            </a:r>
+          </a:p>
+        </p:txBody>
+      </p:sp>
+      <p:sp>
+        <p:nvSpPr>
+          <p:cNvPr id="68" name="TextBox 67"/>
+          <p:cNvSpPr txBox="1"/>
+          <p:nvPr/>
+        </p:nvSpPr>
+        <p:spPr>
+          <a:xfrm>
+            <a:off x="6550000" y="4484480"/>
+            <a:ext cx="4800000" cy="600000"/>
+          </a:xfrm>
+          <a:prstGeom prst="rect">
+            <a:avLst/>
+          </a:prstGeom>
+          <a:noFill/>
+        </p:spPr>
+        <p:txBody>
+          <a:bodyPr wrap="square">
+            <a:spAutoFit/>
+          </a:bodyPr>
+          <a:lstStyle/>
+          <a:p>
+            <a:pPr algn="l"/>
+            <a:r>
+              <a:rPr sz="1000" b="0">
+                <a:solidFill>
+                  <a:srgbClr val="CCD0D8"/>
+                </a:solidFill>
+                <a:latin typeface="Calibri"/>
+              </a:rPr>
+              <a:t>Integración con nuevas fuentes de datos del SII. Soporte multi-región y ampliación de rubros del mapa de clasificación.</a:t>
+            </a:r>
+          </a:p>
+        </p:txBody>
+      </p:sp>
+      <p:sp>
+        <p:nvSpPr>
+          <p:cNvPr id="69" name="TextBox 68"/>
+          <p:cNvSpPr txBox="1"/>
+          <p:nvPr/>
+        </p:nvSpPr>
+        <p:spPr>
+          <a:xfrm>
+            <a:off x="6550000" y="5124480"/>
+            <a:ext cx="4800000" cy="300000"/>
+          </a:xfrm>
+          <a:prstGeom prst="rect">
+            <a:avLst/>
+          </a:prstGeom>
+          <a:noFill/>
+        </p:spPr>
+        <p:txBody>
+          <a:bodyPr wrap="square">
+            <a:spAutoFit/>
+          </a:bodyPr>
+          <a:lstStyle/>
+          <a:p>
+            <a:pPr algn="l"/>
+            <a:r>
+              <a:rPr sz="1300" b="1">
+                <a:solidFill>
+                  <a:srgbClr val="E86C00"/>
+                </a:solidFill>
+                <a:latin typeface="Calibri"/>
+              </a:rPr>
+              <a:t>🛡️  Resiliencia y Calidad</a:t>
+            </a:r>
+          </a:p>
+        </p:txBody>
+      </p:sp>
+      <p:sp>
+        <p:nvSpPr>
+          <p:cNvPr id="70" name="TextBox 69"/>
+          <p:cNvSpPr txBox="1"/>
+          <p:nvPr/>
+        </p:nvSpPr>
+        <p:spPr>
+          <a:xfrm>
+            <a:off x="6550000" y="5434480"/>
+            <a:ext cx="4800000" cy="600000"/>
+          </a:xfrm>
+          <a:prstGeom prst="rect">
+            <a:avLst/>
+          </a:prstGeom>
+          <a:noFill/>
+        </p:spPr>
+        <p:txBody>
+          <a:bodyPr wrap="square">
+            <a:spAutoFit/>
+          </a:bodyPr>
+          <a:lstStyle/>
+          <a:p>
+            <a:pPr algn="l"/>
+            <a:r>
+              <a:rPr sz="1000" b="0">
+                <a:solidFill>
+                  <a:srgbClr val="CCD0D8"/>
+                </a:solidFill>
+                <a:latin typeface="Calibri"/>
+              </a:rPr>
+              <a:t>Alertas automáticas ante cambios en el DOM del SII. Pipeline de CI/CD con tests de regresión y validación de schema.</a:t>
             </a:r>
           </a:p>
         </p:txBody>

</xml_diff>